<commit_message>
fix some bugs about struct
</commit_message>
<xml_diff>
--- a/docs/scade.pptx
+++ b/docs/scade.pptx
@@ -5,7 +5,7 @@
     <p:sldMasterId id="2147483648" r:id="rId1"/>
   </p:sldMasterIdLst>
   <p:notesMasterIdLst>
-    <p:notesMasterId r:id="rId32"/>
+    <p:notesMasterId r:id="rId36"/>
   </p:notesMasterIdLst>
   <p:sldIdLst>
     <p:sldId id="256" r:id="rId2"/>
@@ -37,7 +37,11 @@
     <p:sldId id="279" r:id="rId28"/>
     <p:sldId id="282" r:id="rId29"/>
     <p:sldId id="285" r:id="rId30"/>
-    <p:sldId id="286" r:id="rId31"/>
+    <p:sldId id="287" r:id="rId31"/>
+    <p:sldId id="286" r:id="rId32"/>
+    <p:sldId id="288" r:id="rId33"/>
+    <p:sldId id="289" r:id="rId34"/>
+    <p:sldId id="290" r:id="rId35"/>
   </p:sldIdLst>
   <p:sldSz cx="12192000" cy="6858000"/>
   <p:notesSz cx="6858000" cy="9144000"/>
@@ -226,7 +230,7 @@
           <a:p>
             <a:fld id="{3744C8BF-56B8-46D4-ADA5-A0AF811348DF}" type="datetimeFigureOut">
               <a:rPr lang="zh-CN" altLang="en-US" smtClean="0"/>
-              <a:t>2023/12/4</a:t>
+              <a:t>2023/12/18</a:t>
             </a:fld>
             <a:endParaRPr lang="zh-CN" altLang="en-US"/>
           </a:p>
@@ -724,7 +728,7 @@
           <a:p>
             <a:fld id="{C61D74A4-027F-4A2B-8B92-D0C194C50910}" type="datetimeFigureOut">
               <a:rPr lang="zh-CN" altLang="en-US" smtClean="0"/>
-              <a:t>2023/12/4</a:t>
+              <a:t>2023/12/18</a:t>
             </a:fld>
             <a:endParaRPr lang="zh-CN" altLang="en-US"/>
           </a:p>
@@ -922,7 +926,7 @@
           <a:p>
             <a:fld id="{C61D74A4-027F-4A2B-8B92-D0C194C50910}" type="datetimeFigureOut">
               <a:rPr lang="zh-CN" altLang="en-US" smtClean="0"/>
-              <a:t>2023/12/4</a:t>
+              <a:t>2023/12/18</a:t>
             </a:fld>
             <a:endParaRPr lang="zh-CN" altLang="en-US"/>
           </a:p>
@@ -1130,7 +1134,7 @@
           <a:p>
             <a:fld id="{C61D74A4-027F-4A2B-8B92-D0C194C50910}" type="datetimeFigureOut">
               <a:rPr lang="zh-CN" altLang="en-US" smtClean="0"/>
-              <a:t>2023/12/4</a:t>
+              <a:t>2023/12/18</a:t>
             </a:fld>
             <a:endParaRPr lang="zh-CN" altLang="en-US"/>
           </a:p>
@@ -1328,7 +1332,7 @@
           <a:p>
             <a:fld id="{C61D74A4-027F-4A2B-8B92-D0C194C50910}" type="datetimeFigureOut">
               <a:rPr lang="zh-CN" altLang="en-US" smtClean="0"/>
-              <a:t>2023/12/4</a:t>
+              <a:t>2023/12/18</a:t>
             </a:fld>
             <a:endParaRPr lang="zh-CN" altLang="en-US"/>
           </a:p>
@@ -1603,7 +1607,7 @@
           <a:p>
             <a:fld id="{C61D74A4-027F-4A2B-8B92-D0C194C50910}" type="datetimeFigureOut">
               <a:rPr lang="zh-CN" altLang="en-US" smtClean="0"/>
-              <a:t>2023/12/4</a:t>
+              <a:t>2023/12/18</a:t>
             </a:fld>
             <a:endParaRPr lang="zh-CN" altLang="en-US"/>
           </a:p>
@@ -1868,7 +1872,7 @@
           <a:p>
             <a:fld id="{C61D74A4-027F-4A2B-8B92-D0C194C50910}" type="datetimeFigureOut">
               <a:rPr lang="zh-CN" altLang="en-US" smtClean="0"/>
-              <a:t>2023/12/4</a:t>
+              <a:t>2023/12/18</a:t>
             </a:fld>
             <a:endParaRPr lang="zh-CN" altLang="en-US"/>
           </a:p>
@@ -2280,7 +2284,7 @@
           <a:p>
             <a:fld id="{C61D74A4-027F-4A2B-8B92-D0C194C50910}" type="datetimeFigureOut">
               <a:rPr lang="zh-CN" altLang="en-US" smtClean="0"/>
-              <a:t>2023/12/4</a:t>
+              <a:t>2023/12/18</a:t>
             </a:fld>
             <a:endParaRPr lang="zh-CN" altLang="en-US"/>
           </a:p>
@@ -2421,7 +2425,7 @@
           <a:p>
             <a:fld id="{C61D74A4-027F-4A2B-8B92-D0C194C50910}" type="datetimeFigureOut">
               <a:rPr lang="zh-CN" altLang="en-US" smtClean="0"/>
-              <a:t>2023/12/4</a:t>
+              <a:t>2023/12/18</a:t>
             </a:fld>
             <a:endParaRPr lang="zh-CN" altLang="en-US"/>
           </a:p>
@@ -2534,7 +2538,7 @@
           <a:p>
             <a:fld id="{C61D74A4-027F-4A2B-8B92-D0C194C50910}" type="datetimeFigureOut">
               <a:rPr lang="zh-CN" altLang="en-US" smtClean="0"/>
-              <a:t>2023/12/4</a:t>
+              <a:t>2023/12/18</a:t>
             </a:fld>
             <a:endParaRPr lang="zh-CN" altLang="en-US"/>
           </a:p>
@@ -2845,7 +2849,7 @@
           <a:p>
             <a:fld id="{C61D74A4-027F-4A2B-8B92-D0C194C50910}" type="datetimeFigureOut">
               <a:rPr lang="zh-CN" altLang="en-US" smtClean="0"/>
-              <a:t>2023/12/4</a:t>
+              <a:t>2023/12/18</a:t>
             </a:fld>
             <a:endParaRPr lang="zh-CN" altLang="en-US"/>
           </a:p>
@@ -3133,7 +3137,7 @@
           <a:p>
             <a:fld id="{C61D74A4-027F-4A2B-8B92-D0C194C50910}" type="datetimeFigureOut">
               <a:rPr lang="zh-CN" altLang="en-US" smtClean="0"/>
-              <a:t>2023/12/4</a:t>
+              <a:t>2023/12/18</a:t>
             </a:fld>
             <a:endParaRPr lang="zh-CN" altLang="en-US"/>
           </a:p>
@@ -3374,7 +3378,7 @@
           <a:p>
             <a:fld id="{C61D74A4-027F-4A2B-8B92-D0C194C50910}" type="datetimeFigureOut">
               <a:rPr lang="zh-CN" altLang="en-US" smtClean="0"/>
-              <a:t>2023/12/4</a:t>
+              <a:t>2023/12/18</a:t>
             </a:fld>
             <a:endParaRPr lang="zh-CN" altLang="en-US"/>
           </a:p>
@@ -8198,40 +8202,398 @@
           <a:chExt cx="0" cy="0"/>
         </a:xfrm>
       </p:grpSpPr>
-      <p:pic>
-        <p:nvPicPr>
-          <p:cNvPr id="4" name="图片 3">
-            <a:extLst>
-              <a:ext uri="{FF2B5EF4-FFF2-40B4-BE49-F238E27FC236}">
-                <a16:creationId xmlns:a16="http://schemas.microsoft.com/office/drawing/2014/main" id="{86A6D91B-C8A7-4CB4-8282-F0EF9B7C9BB1}"/>
-              </a:ext>
-            </a:extLst>
-          </p:cNvPr>
-          <p:cNvPicPr>
-            <a:picLocks noChangeAspect="1"/>
-          </p:cNvPicPr>
-          <p:nvPr/>
-        </p:nvPicPr>
-        <p:blipFill>
-          <a:blip r:embed="rId2"/>
-          <a:stretch>
-            <a:fillRect/>
-          </a:stretch>
-        </p:blipFill>
-        <p:spPr>
-          <a:xfrm>
-            <a:off x="683880" y="443587"/>
-            <a:ext cx="5906012" cy="3414056"/>
-          </a:xfrm>
-          <a:prstGeom prst="rect">
-            <a:avLst/>
-          </a:prstGeom>
-        </p:spPr>
-      </p:pic>
+      <p:sp>
+        <p:nvSpPr>
+          <p:cNvPr id="4" name="文本框 3">
+            <a:extLst>
+              <a:ext uri="{FF2B5EF4-FFF2-40B4-BE49-F238E27FC236}">
+                <a16:creationId xmlns:a16="http://schemas.microsoft.com/office/drawing/2014/main" id="{4DA41EFE-7A63-66FC-C34B-F629D51084A7}"/>
+              </a:ext>
+            </a:extLst>
+          </p:cNvPr>
+          <p:cNvSpPr txBox="1"/>
+          <p:nvPr/>
+        </p:nvSpPr>
+        <p:spPr>
+          <a:xfrm>
+            <a:off x="242371" y="187287"/>
+            <a:ext cx="3966072" cy="369332"/>
+          </a:xfrm>
+          <a:prstGeom prst="rect">
+            <a:avLst/>
+          </a:prstGeom>
+          <a:noFill/>
+        </p:spPr>
+        <p:txBody>
+          <a:bodyPr wrap="square" rtlCol="0">
+            <a:spAutoFit/>
+          </a:bodyPr>
+          <a:lstStyle/>
+          <a:p>
+            <a:r>
+              <a:rPr kumimoji="1" lang="zh-CN" altLang="en-US" dirty="0"/>
+              <a:t>结构体</a:t>
+            </a:r>
+          </a:p>
+        </p:txBody>
+      </p:sp>
+      <p:sp>
+        <p:nvSpPr>
+          <p:cNvPr id="5" name="文本框 4">
+            <a:extLst>
+              <a:ext uri="{FF2B5EF4-FFF2-40B4-BE49-F238E27FC236}">
+                <a16:creationId xmlns:a16="http://schemas.microsoft.com/office/drawing/2014/main" id="{2AB61C85-5A42-AD67-8D48-6CFC04F97B58}"/>
+              </a:ext>
+            </a:extLst>
+          </p:cNvPr>
+          <p:cNvSpPr txBox="1"/>
+          <p:nvPr/>
+        </p:nvSpPr>
+        <p:spPr>
+          <a:xfrm>
+            <a:off x="242371" y="749147"/>
+            <a:ext cx="6455884" cy="1754326"/>
+          </a:xfrm>
+          <a:prstGeom prst="rect">
+            <a:avLst/>
+          </a:prstGeom>
+          <a:noFill/>
+        </p:spPr>
+        <p:txBody>
+          <a:bodyPr wrap="square" rtlCol="0">
+            <a:spAutoFit/>
+          </a:bodyPr>
+          <a:lstStyle/>
+          <a:p>
+            <a:r>
+              <a:rPr kumimoji="1" lang="en" altLang="zh-CN" dirty="0" err="1"/>
+              <a:t>Type_expr</a:t>
+            </a:r>
+            <a:r>
+              <a:rPr kumimoji="1" lang="en" altLang="zh-CN" dirty="0"/>
+              <a:t> :: = {  </a:t>
+            </a:r>
+            <a:r>
+              <a:rPr kumimoji="1" lang="en" altLang="zh-CN" dirty="0" err="1"/>
+              <a:t>Field_decl</a:t>
+            </a:r>
+            <a:r>
+              <a:rPr kumimoji="1" lang="en" altLang="zh-CN" dirty="0"/>
+              <a:t> Type_expr_1 } Type_expr_2</a:t>
+            </a:r>
+          </a:p>
+          <a:p>
+            <a:r>
+              <a:rPr kumimoji="1" lang="en" altLang="zh-CN" dirty="0"/>
+              <a:t>Type_expr_1 ::= , </a:t>
+            </a:r>
+            <a:r>
+              <a:rPr kumimoji="1" lang="en" altLang="zh-CN" dirty="0" err="1"/>
+              <a:t>Field_decl</a:t>
+            </a:r>
+            <a:r>
+              <a:rPr kumimoji="1" lang="en" altLang="zh-CN" dirty="0"/>
+              <a:t> Type_expr_1</a:t>
+            </a:r>
+          </a:p>
+          <a:p>
+            <a:r>
+              <a:rPr kumimoji="1" lang="en" altLang="zh-CN" dirty="0"/>
+              <a:t>             ::= $</a:t>
+            </a:r>
+          </a:p>
+          <a:p>
+            <a:r>
+              <a:rPr kumimoji="1" lang="en" altLang="zh-CN" dirty="0"/>
+              <a:t>Type_expr_2 ::= ^ Expr Type_expr_2</a:t>
+            </a:r>
+          </a:p>
+          <a:p>
+            <a:r>
+              <a:rPr kumimoji="1" lang="en" altLang="zh-CN" dirty="0"/>
+              <a:t>             ::= $</a:t>
+            </a:r>
+          </a:p>
+          <a:p>
+            <a:r>
+              <a:rPr kumimoji="1" lang="en" altLang="zh-CN" dirty="0" err="1"/>
+              <a:t>Field_decl</a:t>
+            </a:r>
+            <a:r>
+              <a:rPr kumimoji="1" lang="en" altLang="zh-CN" dirty="0"/>
+              <a:t> ::= id : </a:t>
+            </a:r>
+            <a:r>
+              <a:rPr kumimoji="1" lang="en" altLang="zh-CN" dirty="0" err="1"/>
+              <a:t>Type_expr</a:t>
+            </a:r>
+            <a:endParaRPr kumimoji="1" lang="en" altLang="zh-CN" dirty="0"/>
+          </a:p>
+        </p:txBody>
+      </p:sp>
+      <p:sp>
+        <p:nvSpPr>
+          <p:cNvPr id="6" name="文本框 5">
+            <a:extLst>
+              <a:ext uri="{FF2B5EF4-FFF2-40B4-BE49-F238E27FC236}">
+                <a16:creationId xmlns:a16="http://schemas.microsoft.com/office/drawing/2014/main" id="{B8012144-4CF0-9E72-035C-4015FA19F786}"/>
+              </a:ext>
+            </a:extLst>
+          </p:cNvPr>
+          <p:cNvSpPr txBox="1"/>
+          <p:nvPr/>
+        </p:nvSpPr>
+        <p:spPr>
+          <a:xfrm>
+            <a:off x="374573" y="2776251"/>
+            <a:ext cx="8108415" cy="369332"/>
+          </a:xfrm>
+          <a:prstGeom prst="rect">
+            <a:avLst/>
+          </a:prstGeom>
+          <a:noFill/>
+        </p:spPr>
+        <p:txBody>
+          <a:bodyPr wrap="square" rtlCol="0">
+            <a:spAutoFit/>
+          </a:bodyPr>
+          <a:lstStyle/>
+          <a:p>
+            <a:r>
+              <a:rPr kumimoji="1" lang="zh-CN" altLang="en-US" b="1" dirty="0"/>
+              <a:t>使用</a:t>
+            </a:r>
+            <a:r>
+              <a:rPr kumimoji="1" lang="en-US" altLang="zh-CN" b="1" dirty="0"/>
+              <a:t>type</a:t>
+            </a:r>
+            <a:r>
+              <a:rPr kumimoji="1" lang="zh-CN" altLang="en-US" b="1" dirty="0"/>
+              <a:t>定义结构体</a:t>
+            </a:r>
+            <a:endParaRPr kumimoji="1" lang="en-US" altLang="zh-CN" b="1" dirty="0"/>
+          </a:p>
+        </p:txBody>
+      </p:sp>
+      <p:sp>
+        <p:nvSpPr>
+          <p:cNvPr id="2" name="文本框 1">
+            <a:extLst>
+              <a:ext uri="{FF2B5EF4-FFF2-40B4-BE49-F238E27FC236}">
+                <a16:creationId xmlns:a16="http://schemas.microsoft.com/office/drawing/2014/main" id="{04CBF17A-84B8-4CF2-77FF-21AA33163087}"/>
+              </a:ext>
+            </a:extLst>
+          </p:cNvPr>
+          <p:cNvSpPr txBox="1"/>
+          <p:nvPr/>
+        </p:nvSpPr>
+        <p:spPr>
+          <a:xfrm>
+            <a:off x="506776" y="3272010"/>
+            <a:ext cx="5871990" cy="2585323"/>
+          </a:xfrm>
+          <a:prstGeom prst="rect">
+            <a:avLst/>
+          </a:prstGeom>
+          <a:noFill/>
+        </p:spPr>
+        <p:txBody>
+          <a:bodyPr wrap="square" rtlCol="0">
+            <a:spAutoFit/>
+          </a:bodyPr>
+          <a:lstStyle/>
+          <a:p>
+            <a:r>
+              <a:rPr lang="en" altLang="zh-CN" dirty="0" err="1"/>
+              <a:t>Scade</a:t>
+            </a:r>
+            <a:r>
+              <a:rPr lang="zh-CN" altLang="en" dirty="0"/>
+              <a:t>程序</a:t>
+            </a:r>
+            <a:endParaRPr lang="en-US" altLang="zh-CN" dirty="0"/>
+          </a:p>
+          <a:p>
+            <a:r>
+              <a:rPr lang="en" altLang="zh-CN" dirty="0"/>
+              <a:t>type t2={tt1:bool,tt2:int32,tt3:float32};</a:t>
+            </a:r>
+          </a:p>
+          <a:p>
+            <a:endParaRPr kumimoji="1" lang="en" altLang="zh-CN" dirty="0"/>
+          </a:p>
+          <a:p>
+            <a:r>
+              <a:rPr kumimoji="1" lang="zh-CN" altLang="en" dirty="0"/>
+              <a:t>转化后</a:t>
+            </a:r>
+            <a:r>
+              <a:rPr kumimoji="1" lang="en-US" altLang="zh-CN" dirty="0"/>
+              <a:t>C</a:t>
+            </a:r>
+            <a:r>
+              <a:rPr kumimoji="1" lang="zh-CN" altLang="en-US" dirty="0"/>
+              <a:t>程序</a:t>
+            </a:r>
+            <a:endParaRPr kumimoji="1" lang="en-US" altLang="zh-CN" dirty="0"/>
+          </a:p>
+          <a:p>
+            <a:r>
+              <a:rPr lang="en" altLang="zh-CN" dirty="0"/>
+              <a:t>typedef struct { </a:t>
+            </a:r>
+          </a:p>
+          <a:p>
+            <a:r>
+              <a:rPr lang="zh-CN" altLang="en-US" dirty="0"/>
+              <a:t>     </a:t>
+            </a:r>
+            <a:r>
+              <a:rPr lang="en" altLang="zh-CN" dirty="0"/>
+              <a:t>bool tt1; </a:t>
+            </a:r>
+          </a:p>
+          <a:p>
+            <a:r>
+              <a:rPr lang="zh-CN" altLang="en-US" dirty="0"/>
+              <a:t>     </a:t>
+            </a:r>
+            <a:r>
+              <a:rPr lang="en" altLang="zh-CN" dirty="0"/>
+              <a:t>int tt2; </a:t>
+            </a:r>
+          </a:p>
+          <a:p>
+            <a:r>
+              <a:rPr lang="zh-CN" altLang="en-US" dirty="0"/>
+              <a:t>     </a:t>
+            </a:r>
+            <a:r>
+              <a:rPr lang="en" altLang="zh-CN" dirty="0"/>
+              <a:t>float tt3; </a:t>
+            </a:r>
+          </a:p>
+          <a:p>
+            <a:r>
+              <a:rPr lang="en" altLang="zh-CN" dirty="0"/>
+              <a:t>}t2;</a:t>
+            </a:r>
+            <a:endParaRPr kumimoji="1" lang="zh-CN" altLang="en-US" dirty="0"/>
+          </a:p>
+        </p:txBody>
+      </p:sp>
+      <p:sp>
+        <p:nvSpPr>
+          <p:cNvPr id="7" name="文本框 6">
+            <a:extLst>
+              <a:ext uri="{FF2B5EF4-FFF2-40B4-BE49-F238E27FC236}">
+                <a16:creationId xmlns:a16="http://schemas.microsoft.com/office/drawing/2014/main" id="{47540211-1E29-EE43-C91B-D5F08304F497}"/>
+              </a:ext>
+            </a:extLst>
+          </p:cNvPr>
+          <p:cNvSpPr txBox="1"/>
+          <p:nvPr/>
+        </p:nvSpPr>
+        <p:spPr>
+          <a:xfrm>
+            <a:off x="5464366" y="3241094"/>
+            <a:ext cx="4627085" cy="2585323"/>
+          </a:xfrm>
+          <a:prstGeom prst="rect">
+            <a:avLst/>
+          </a:prstGeom>
+          <a:noFill/>
+        </p:spPr>
+        <p:txBody>
+          <a:bodyPr wrap="square" rtlCol="0">
+            <a:spAutoFit/>
+          </a:bodyPr>
+          <a:lstStyle/>
+          <a:p>
+            <a:r>
+              <a:rPr kumimoji="1" lang="en-US" altLang="zh-CN" dirty="0" err="1"/>
+              <a:t>Scade</a:t>
+            </a:r>
+            <a:r>
+              <a:rPr kumimoji="1" lang="zh-CN" altLang="en-US" dirty="0"/>
+              <a:t>程序</a:t>
+            </a:r>
+            <a:endParaRPr kumimoji="1" lang="en-US" altLang="zh-CN" dirty="0"/>
+          </a:p>
+          <a:p>
+            <a:r>
+              <a:rPr lang="en" altLang="zh-CN" dirty="0"/>
+              <a:t>type t3={tt1:bool,tt2:int32,tt3:float32}^2;</a:t>
+            </a:r>
+            <a:endParaRPr kumimoji="1" lang="en-US" altLang="zh-CN" dirty="0"/>
+          </a:p>
+          <a:p>
+            <a:endParaRPr kumimoji="1" lang="en-US" altLang="zh-CN" dirty="0"/>
+          </a:p>
+          <a:p>
+            <a:r>
+              <a:rPr kumimoji="1" lang="zh-CN" altLang="en-US" dirty="0"/>
+              <a:t>转化后</a:t>
+            </a:r>
+            <a:r>
+              <a:rPr kumimoji="1" lang="en-US" altLang="zh-CN" dirty="0"/>
+              <a:t>C</a:t>
+            </a:r>
+            <a:r>
+              <a:rPr kumimoji="1" lang="zh-CN" altLang="en-US" dirty="0"/>
+              <a:t>程序</a:t>
+            </a:r>
+            <a:endParaRPr kumimoji="1" lang="en-US" altLang="zh-CN" dirty="0"/>
+          </a:p>
+          <a:p>
+            <a:r>
+              <a:rPr lang="en" altLang="zh-CN" dirty="0"/>
+              <a:t>typedef struct { </a:t>
+            </a:r>
+          </a:p>
+          <a:p>
+            <a:r>
+              <a:rPr lang="zh-CN" altLang="en-US" dirty="0"/>
+              <a:t>    </a:t>
+            </a:r>
+            <a:r>
+              <a:rPr lang="en" altLang="zh-CN" dirty="0"/>
+              <a:t>bool tt1; </a:t>
+            </a:r>
+          </a:p>
+          <a:p>
+            <a:r>
+              <a:rPr lang="zh-CN" altLang="en-US" dirty="0"/>
+              <a:t>    </a:t>
+            </a:r>
+            <a:r>
+              <a:rPr lang="en" altLang="zh-CN" dirty="0"/>
+              <a:t>int tt2; </a:t>
+            </a:r>
+          </a:p>
+          <a:p>
+            <a:r>
+              <a:rPr lang="zh-CN" altLang="en-US" dirty="0"/>
+              <a:t>    </a:t>
+            </a:r>
+            <a:r>
+              <a:rPr lang="en" altLang="zh-CN" dirty="0"/>
+              <a:t>float tt3; </a:t>
+            </a:r>
+          </a:p>
+          <a:p>
+            <a:r>
+              <a:rPr lang="en" altLang="zh-CN" dirty="0"/>
+              <a:t>}t3[2];</a:t>
+            </a:r>
+            <a:endParaRPr kumimoji="1" lang="en-US" altLang="zh-CN" dirty="0"/>
+          </a:p>
+        </p:txBody>
+      </p:sp>
     </p:spTree>
     <p:extLst>
       <p:ext uri="{BB962C8B-B14F-4D97-AF65-F5344CB8AC3E}">
-        <p14:creationId xmlns:p14="http://schemas.microsoft.com/office/powerpoint/2010/main" val="2852107379"/>
+        <p14:creationId xmlns:p14="http://schemas.microsoft.com/office/powerpoint/2010/main" val="2628688210"/>
       </p:ext>
     </p:extLst>
   </p:cSld>
@@ -8450,12 +8812,822 @@
           <a:chExt cx="0" cy="0"/>
         </a:xfrm>
       </p:grpSpPr>
+      <p:sp>
+        <p:nvSpPr>
+          <p:cNvPr id="4" name="文本框 3">
+            <a:extLst>
+              <a:ext uri="{FF2B5EF4-FFF2-40B4-BE49-F238E27FC236}">
+                <a16:creationId xmlns:a16="http://schemas.microsoft.com/office/drawing/2014/main" id="{1AAD0F7B-395D-3A94-88BA-A8C377ECFC8A}"/>
+              </a:ext>
+            </a:extLst>
+          </p:cNvPr>
+          <p:cNvSpPr txBox="1"/>
+          <p:nvPr/>
+        </p:nvSpPr>
+        <p:spPr>
+          <a:xfrm>
+            <a:off x="198304" y="209320"/>
+            <a:ext cx="6566053" cy="369332"/>
+          </a:xfrm>
+          <a:prstGeom prst="rect">
+            <a:avLst/>
+          </a:prstGeom>
+          <a:noFill/>
+        </p:spPr>
+        <p:txBody>
+          <a:bodyPr wrap="square" rtlCol="0">
+            <a:spAutoFit/>
+          </a:bodyPr>
+          <a:lstStyle/>
+          <a:p>
+            <a:r>
+              <a:rPr kumimoji="1" lang="zh-CN" altLang="en-US" b="1" dirty="0"/>
+              <a:t>使用</a:t>
+            </a:r>
+            <a:r>
+              <a:rPr kumimoji="1" lang="en-US" altLang="zh-CN" b="1" dirty="0"/>
+              <a:t>const</a:t>
+            </a:r>
+            <a:r>
+              <a:rPr kumimoji="1" lang="zh-CN" altLang="en-US" b="1" dirty="0"/>
+              <a:t>定义并初始化</a:t>
+            </a:r>
+          </a:p>
+        </p:txBody>
+      </p:sp>
+      <p:sp>
+        <p:nvSpPr>
+          <p:cNvPr id="5" name="文本框 4">
+            <a:extLst>
+              <a:ext uri="{FF2B5EF4-FFF2-40B4-BE49-F238E27FC236}">
+                <a16:creationId xmlns:a16="http://schemas.microsoft.com/office/drawing/2014/main" id="{F269A5F3-23AD-7B2A-DAC6-20DBA1E08409}"/>
+              </a:ext>
+            </a:extLst>
+          </p:cNvPr>
+          <p:cNvSpPr txBox="1"/>
+          <p:nvPr/>
+        </p:nvSpPr>
+        <p:spPr>
+          <a:xfrm>
+            <a:off x="198304" y="3526999"/>
+            <a:ext cx="2492990" cy="369332"/>
+          </a:xfrm>
+          <a:prstGeom prst="rect">
+            <a:avLst/>
+          </a:prstGeom>
+          <a:noFill/>
+        </p:spPr>
+        <p:txBody>
+          <a:bodyPr wrap="none" rtlCol="0">
+            <a:spAutoFit/>
+          </a:bodyPr>
+          <a:lstStyle/>
+          <a:p>
+            <a:r>
+              <a:rPr kumimoji="1" lang="zh-CN" altLang="en-US" b="1" dirty="0"/>
+              <a:t>直接用于输入输出参数</a:t>
+            </a:r>
+          </a:p>
+        </p:txBody>
+      </p:sp>
+      <p:sp>
+        <p:nvSpPr>
+          <p:cNvPr id="2" name="文本框 1">
+            <a:extLst>
+              <a:ext uri="{FF2B5EF4-FFF2-40B4-BE49-F238E27FC236}">
+                <a16:creationId xmlns:a16="http://schemas.microsoft.com/office/drawing/2014/main" id="{C29A989B-1342-875B-830D-2D32D37381E3}"/>
+              </a:ext>
+            </a:extLst>
+          </p:cNvPr>
+          <p:cNvSpPr txBox="1"/>
+          <p:nvPr/>
+        </p:nvSpPr>
+        <p:spPr>
+          <a:xfrm>
+            <a:off x="198304" y="760164"/>
+            <a:ext cx="6037243" cy="2585323"/>
+          </a:xfrm>
+          <a:prstGeom prst="rect">
+            <a:avLst/>
+          </a:prstGeom>
+          <a:noFill/>
+        </p:spPr>
+        <p:txBody>
+          <a:bodyPr wrap="square" rtlCol="0">
+            <a:spAutoFit/>
+          </a:bodyPr>
+          <a:lstStyle/>
+          <a:p>
+            <a:r>
+              <a:rPr lang="en" altLang="zh-CN" dirty="0"/>
+              <a:t>type t2={tt1:bool,tt2:int32,tt3:float32}; </a:t>
+            </a:r>
+          </a:p>
+          <a:p>
+            <a:endParaRPr lang="en-US" altLang="zh-CN" dirty="0"/>
+          </a:p>
+          <a:p>
+            <a:r>
+              <a:rPr lang="en" altLang="zh-CN" dirty="0"/>
+              <a:t>const c7:t2={tt1:false,tt2:8,tt3:0.2}; </a:t>
+            </a:r>
+          </a:p>
+          <a:p>
+            <a:endParaRPr lang="en" altLang="zh-CN" dirty="0"/>
+          </a:p>
+          <a:p>
+            <a:r>
+              <a:rPr lang="en" altLang="zh-CN" dirty="0"/>
+              <a:t>type t3={tt1:bool,tt2:int32,tt3:float32}^2; </a:t>
+            </a:r>
+          </a:p>
+          <a:p>
+            <a:endParaRPr lang="en" altLang="zh-CN" dirty="0"/>
+          </a:p>
+          <a:p>
+            <a:r>
+              <a:rPr lang="en" altLang="zh-CN" dirty="0"/>
+              <a:t>const c8:t3=[{tt1:false,tt2:3,tt3:0.1},{tt1:true,tt2:2,tt3:0.2}];</a:t>
+            </a:r>
+          </a:p>
+          <a:p>
+            <a:endParaRPr kumimoji="1" lang="en" altLang="zh-CN" dirty="0"/>
+          </a:p>
+          <a:p>
+            <a:r>
+              <a:rPr lang="en" altLang="zh-CN" dirty="0"/>
+              <a:t>const c9:{tt1:bool,tt2:int8}={tt1:false,tt2:8};</a:t>
+            </a:r>
+            <a:endParaRPr kumimoji="1" lang="zh-CN" altLang="en-US" dirty="0"/>
+          </a:p>
+        </p:txBody>
+      </p:sp>
+      <p:sp>
+        <p:nvSpPr>
+          <p:cNvPr id="3" name="文本框 2">
+            <a:extLst>
+              <a:ext uri="{FF2B5EF4-FFF2-40B4-BE49-F238E27FC236}">
+                <a16:creationId xmlns:a16="http://schemas.microsoft.com/office/drawing/2014/main" id="{641B304B-640A-D613-97E1-122CCD2E428B}"/>
+              </a:ext>
+            </a:extLst>
+          </p:cNvPr>
+          <p:cNvSpPr txBox="1"/>
+          <p:nvPr/>
+        </p:nvSpPr>
+        <p:spPr>
+          <a:xfrm>
+            <a:off x="6096000" y="578652"/>
+            <a:ext cx="5482728" cy="2862322"/>
+          </a:xfrm>
+          <a:prstGeom prst="rect">
+            <a:avLst/>
+          </a:prstGeom>
+          <a:noFill/>
+        </p:spPr>
+        <p:txBody>
+          <a:bodyPr wrap="square" rtlCol="0">
+            <a:spAutoFit/>
+          </a:bodyPr>
+          <a:lstStyle/>
+          <a:p>
+            <a:r>
+              <a:rPr kumimoji="1" lang="zh-CN" altLang="en-US" dirty="0"/>
+              <a:t>转化后</a:t>
+            </a:r>
+            <a:r>
+              <a:rPr kumimoji="1" lang="en-US" altLang="zh-CN" dirty="0"/>
+              <a:t>C</a:t>
+            </a:r>
+            <a:r>
+              <a:rPr kumimoji="1" lang="zh-CN" altLang="en-US" dirty="0"/>
+              <a:t>程序</a:t>
+            </a:r>
+            <a:endParaRPr kumimoji="1" lang="en-US" altLang="zh-CN" dirty="0"/>
+          </a:p>
+          <a:p>
+            <a:r>
+              <a:rPr lang="en" altLang="zh-CN" dirty="0"/>
+              <a:t>extern const t2 c7 = {false,8,0.2};</a:t>
+            </a:r>
+            <a:endParaRPr kumimoji="1" lang="en-US" altLang="zh-CN" dirty="0"/>
+          </a:p>
+          <a:p>
+            <a:endParaRPr kumimoji="1" lang="en-US" altLang="zh-CN" dirty="0"/>
+          </a:p>
+          <a:p>
+            <a:r>
+              <a:rPr lang="en" altLang="zh-CN" dirty="0"/>
+              <a:t>extern const t3 c8 = { {false,</a:t>
+            </a:r>
+            <a:r>
+              <a:rPr lang="en-US" altLang="zh-CN" dirty="0"/>
+              <a:t>3,</a:t>
+            </a:r>
+            <a:r>
+              <a:rPr lang="en" altLang="zh-CN" dirty="0"/>
+              <a:t>0.1},{true,2,0.2} };</a:t>
+            </a:r>
+          </a:p>
+          <a:p>
+            <a:endParaRPr kumimoji="1" lang="en-US" altLang="zh-CN" dirty="0"/>
+          </a:p>
+          <a:p>
+            <a:r>
+              <a:rPr lang="en" altLang="zh-CN" dirty="0"/>
+              <a:t>typedef struct { </a:t>
+            </a:r>
+          </a:p>
+          <a:p>
+            <a:r>
+              <a:rPr lang="en" altLang="zh-CN" dirty="0"/>
+              <a:t>    bool tt1; </a:t>
+            </a:r>
+          </a:p>
+          <a:p>
+            <a:r>
+              <a:rPr lang="en" altLang="zh-CN" dirty="0"/>
+              <a:t>    int tt2; </a:t>
+            </a:r>
+          </a:p>
+          <a:p>
+            <a:r>
+              <a:rPr lang="en" altLang="zh-CN" dirty="0"/>
+              <a:t>}</a:t>
+            </a:r>
+            <a:r>
+              <a:rPr lang="en" altLang="zh-CN" dirty="0" err="1"/>
+              <a:t>tmp</a:t>
+            </a:r>
+            <a:r>
+              <a:rPr lang="en" altLang="zh-CN" dirty="0"/>
+              <a:t>;</a:t>
+            </a:r>
+            <a:endParaRPr kumimoji="1" lang="en-US" altLang="zh-CN" dirty="0"/>
+          </a:p>
+          <a:p>
+            <a:r>
+              <a:rPr lang="en" altLang="zh-CN" dirty="0"/>
+              <a:t>extern const </a:t>
+            </a:r>
+            <a:r>
+              <a:rPr lang="en" altLang="zh-CN" dirty="0" err="1"/>
+              <a:t>tmp</a:t>
+            </a:r>
+            <a:r>
+              <a:rPr lang="en" altLang="zh-CN" dirty="0"/>
+              <a:t> c9 = { false,8 };</a:t>
+            </a:r>
+            <a:endParaRPr kumimoji="1" lang="en" altLang="zh-CN" dirty="0"/>
+          </a:p>
+        </p:txBody>
+      </p:sp>
+      <p:sp>
+        <p:nvSpPr>
+          <p:cNvPr id="6" name="文本框 5">
+            <a:extLst>
+              <a:ext uri="{FF2B5EF4-FFF2-40B4-BE49-F238E27FC236}">
+                <a16:creationId xmlns:a16="http://schemas.microsoft.com/office/drawing/2014/main" id="{7B425160-48CA-BC6A-145B-C892A627DC0D}"/>
+              </a:ext>
+            </a:extLst>
+          </p:cNvPr>
+          <p:cNvSpPr txBox="1"/>
+          <p:nvPr/>
+        </p:nvSpPr>
+        <p:spPr>
+          <a:xfrm>
+            <a:off x="198304" y="4087258"/>
+            <a:ext cx="6367749" cy="1200329"/>
+          </a:xfrm>
+          <a:prstGeom prst="rect">
+            <a:avLst/>
+          </a:prstGeom>
+          <a:noFill/>
+        </p:spPr>
+        <p:txBody>
+          <a:bodyPr wrap="square" rtlCol="0">
+            <a:spAutoFit/>
+          </a:bodyPr>
+          <a:lstStyle/>
+          <a:p>
+            <a:r>
+              <a:rPr lang="en" altLang="zh-CN" dirty="0"/>
+              <a:t>function </a:t>
+            </a:r>
+            <a:r>
+              <a:rPr lang="en" altLang="zh-CN" dirty="0" err="1"/>
+              <a:t>structTest</a:t>
+            </a:r>
+            <a:r>
+              <a:rPr lang="en" altLang="zh-CN" dirty="0"/>
+              <a:t>(in1:{t1:int32}) returns(o1:int32) </a:t>
+            </a:r>
+          </a:p>
+          <a:p>
+            <a:r>
+              <a:rPr lang="en" altLang="zh-CN" dirty="0"/>
+              <a:t>let </a:t>
+            </a:r>
+          </a:p>
+          <a:p>
+            <a:r>
+              <a:rPr lang="en" altLang="zh-CN" dirty="0"/>
+              <a:t>    o1=in1.t1+3; </a:t>
+            </a:r>
+          </a:p>
+          <a:p>
+            <a:r>
+              <a:rPr lang="en" altLang="zh-CN" dirty="0" err="1"/>
+              <a:t>tel</a:t>
+            </a:r>
+            <a:endParaRPr kumimoji="1" lang="zh-CN" altLang="en-US" dirty="0"/>
+          </a:p>
+        </p:txBody>
+      </p:sp>
+      <p:sp>
+        <p:nvSpPr>
+          <p:cNvPr id="7" name="文本框 6">
+            <a:extLst>
+              <a:ext uri="{FF2B5EF4-FFF2-40B4-BE49-F238E27FC236}">
+                <a16:creationId xmlns:a16="http://schemas.microsoft.com/office/drawing/2014/main" id="{6F0CD1F6-6926-493C-9A6A-2D674456FFF7}"/>
+              </a:ext>
+            </a:extLst>
+          </p:cNvPr>
+          <p:cNvSpPr txBox="1"/>
+          <p:nvPr/>
+        </p:nvSpPr>
+        <p:spPr>
+          <a:xfrm>
+            <a:off x="5716471" y="4739850"/>
+            <a:ext cx="6323860" cy="1477328"/>
+          </a:xfrm>
+          <a:prstGeom prst="rect">
+            <a:avLst/>
+          </a:prstGeom>
+          <a:noFill/>
+        </p:spPr>
+        <p:txBody>
+          <a:bodyPr wrap="square" rtlCol="0">
+            <a:spAutoFit/>
+          </a:bodyPr>
+          <a:lstStyle/>
+          <a:p>
+            <a:r>
+              <a:rPr lang="en-US" altLang="zh-CN"/>
+              <a:t>void structTest(inC_structTest *inC, outC_structTest *outC)</a:t>
+            </a:r>
+          </a:p>
+          <a:p>
+            <a:r>
+              <a:rPr lang="en-US" altLang="zh-CN"/>
+              <a:t>{</a:t>
+            </a:r>
+          </a:p>
+          <a:p>
+            <a:r>
+              <a:rPr lang="en-US" altLang="zh-CN"/>
+              <a:t>  outC-&gt;o1 = inC-&gt;in1.t1 + kcg_lit_int32(3);</a:t>
+            </a:r>
+          </a:p>
+          <a:p>
+            <a:r>
+              <a:rPr lang="en-US" altLang="zh-CN"/>
+              <a:t>}</a:t>
+            </a:r>
+          </a:p>
+          <a:p>
+            <a:endParaRPr lang="zh-CN" altLang="en-US"/>
+          </a:p>
+        </p:txBody>
+      </p:sp>
+      <p:sp>
+        <p:nvSpPr>
+          <p:cNvPr id="8" name="文本框 7">
+            <a:extLst>
+              <a:ext uri="{FF2B5EF4-FFF2-40B4-BE49-F238E27FC236}">
+                <a16:creationId xmlns:a16="http://schemas.microsoft.com/office/drawing/2014/main" id="{642F8D1B-2C49-41BE-BC91-86B0CD34C4C8}"/>
+              </a:ext>
+            </a:extLst>
+          </p:cNvPr>
+          <p:cNvSpPr txBox="1"/>
+          <p:nvPr/>
+        </p:nvSpPr>
+        <p:spPr>
+          <a:xfrm>
+            <a:off x="9240294" y="3711665"/>
+            <a:ext cx="2672178" cy="1200329"/>
+          </a:xfrm>
+          <a:prstGeom prst="rect">
+            <a:avLst/>
+          </a:prstGeom>
+          <a:noFill/>
+        </p:spPr>
+        <p:txBody>
+          <a:bodyPr wrap="square" rtlCol="0">
+            <a:spAutoFit/>
+          </a:bodyPr>
+          <a:lstStyle/>
+          <a:p>
+            <a:r>
+              <a:rPr lang="en-US" altLang="zh-CN"/>
+              <a:t>typedef struct { </a:t>
+            </a:r>
+          </a:p>
+          <a:p>
+            <a:r>
+              <a:rPr lang="en-US" altLang="zh-CN"/>
+              <a:t>tmp2 in1; </a:t>
+            </a:r>
+          </a:p>
+          <a:p>
+            <a:r>
+              <a:rPr lang="en-US" altLang="zh-CN"/>
+              <a:t>} inC_structTest;</a:t>
+            </a:r>
+          </a:p>
+          <a:p>
+            <a:endParaRPr lang="zh-CN" altLang="en-US"/>
+          </a:p>
+        </p:txBody>
+      </p:sp>
+      <p:sp>
+        <p:nvSpPr>
+          <p:cNvPr id="9" name="文本框 8">
+            <a:extLst>
+              <a:ext uri="{FF2B5EF4-FFF2-40B4-BE49-F238E27FC236}">
+                <a16:creationId xmlns:a16="http://schemas.microsoft.com/office/drawing/2014/main" id="{D1C60878-2AE5-468A-B519-123A0F8E3A4A}"/>
+              </a:ext>
+            </a:extLst>
+          </p:cNvPr>
+          <p:cNvSpPr txBox="1"/>
+          <p:nvPr/>
+        </p:nvSpPr>
+        <p:spPr>
+          <a:xfrm>
+            <a:off x="6235547" y="3737603"/>
+            <a:ext cx="3604334" cy="1200329"/>
+          </a:xfrm>
+          <a:prstGeom prst="rect">
+            <a:avLst/>
+          </a:prstGeom>
+          <a:noFill/>
+        </p:spPr>
+        <p:txBody>
+          <a:bodyPr wrap="square" rtlCol="0">
+            <a:spAutoFit/>
+          </a:bodyPr>
+          <a:lstStyle/>
+          <a:p>
+            <a:r>
+              <a:rPr lang="en-US" altLang="zh-CN"/>
+              <a:t>typedef struct { </a:t>
+            </a:r>
+          </a:p>
+          <a:p>
+            <a:r>
+              <a:rPr lang="en-US" altLang="zh-CN"/>
+              <a:t>kcg_int32 t1; </a:t>
+            </a:r>
+          </a:p>
+          <a:p>
+            <a:r>
+              <a:rPr lang="en-US" altLang="zh-CN"/>
+              <a:t>} tmp2;</a:t>
+            </a:r>
+          </a:p>
+          <a:p>
+            <a:endParaRPr lang="zh-CN" altLang="en-US"/>
+          </a:p>
+        </p:txBody>
+      </p:sp>
+    </p:spTree>
+    <p:extLst>
+      <p:ext uri="{BB962C8B-B14F-4D97-AF65-F5344CB8AC3E}">
+        <p14:creationId xmlns:p14="http://schemas.microsoft.com/office/powerpoint/2010/main" val="2575251222"/>
+      </p:ext>
+    </p:extLst>
+  </p:cSld>
+  <p:clrMapOvr>
+    <a:masterClrMapping/>
+  </p:clrMapOvr>
+</p:sld>
+</file>
+
+<file path=ppt/slides/slide31.xml><?xml version="1.0" encoding="utf-8"?>
+<p:sld xmlns:a="http://schemas.openxmlformats.org/drawingml/2006/main" xmlns:r="http://schemas.openxmlformats.org/officeDocument/2006/relationships" xmlns:p="http://schemas.openxmlformats.org/presentationml/2006/main">
+  <p:cSld>
+    <p:spTree>
+      <p:nvGrpSpPr>
+        <p:cNvPr id="1" name=""/>
+        <p:cNvGrpSpPr/>
+        <p:nvPr/>
+      </p:nvGrpSpPr>
+      <p:grpSpPr>
+        <a:xfrm>
+          <a:off x="0" y="0"/>
+          <a:ext cx="0" cy="0"/>
+          <a:chOff x="0" y="0"/>
+          <a:chExt cx="0" cy="0"/>
+        </a:xfrm>
+      </p:grpSpPr>
+      <p:sp>
+        <p:nvSpPr>
+          <p:cNvPr id="4" name="文本框 3">
+            <a:extLst>
+              <a:ext uri="{FF2B5EF4-FFF2-40B4-BE49-F238E27FC236}">
+                <a16:creationId xmlns:a16="http://schemas.microsoft.com/office/drawing/2014/main" id="{B8712464-D556-0B07-34F4-E20AC57645CD}"/>
+              </a:ext>
+            </a:extLst>
+          </p:cNvPr>
+          <p:cNvSpPr txBox="1"/>
+          <p:nvPr/>
+        </p:nvSpPr>
+        <p:spPr>
+          <a:xfrm>
+            <a:off x="308472" y="176270"/>
+            <a:ext cx="4682169" cy="1477328"/>
+          </a:xfrm>
+          <a:prstGeom prst="rect">
+            <a:avLst/>
+          </a:prstGeom>
+          <a:noFill/>
+        </p:spPr>
+        <p:txBody>
+          <a:bodyPr wrap="square" rtlCol="0">
+            <a:spAutoFit/>
+          </a:bodyPr>
+          <a:lstStyle/>
+          <a:p>
+            <a:r>
+              <a:rPr kumimoji="1" lang="en" altLang="zh-CN" dirty="0" err="1"/>
+              <a:t>Struct_expr</a:t>
+            </a:r>
+            <a:r>
+              <a:rPr kumimoji="1" lang="en" altLang="zh-CN" dirty="0"/>
+              <a:t> ::= </a:t>
+            </a:r>
+            <a:r>
+              <a:rPr kumimoji="1" lang="en" altLang="zh-CN" dirty="0" err="1"/>
+              <a:t>Epxr</a:t>
+            </a:r>
+            <a:r>
+              <a:rPr kumimoji="1" lang="en" altLang="zh-CN" dirty="0"/>
+              <a:t> . id</a:t>
+            </a:r>
+          </a:p>
+          <a:p>
+            <a:r>
+              <a:rPr kumimoji="1" lang="en" altLang="zh-CN" dirty="0"/>
+              <a:t>                   ::= { </a:t>
+            </a:r>
+            <a:r>
+              <a:rPr kumimoji="1" lang="en" altLang="zh-CN" dirty="0" err="1"/>
+              <a:t>Label_expr</a:t>
+            </a:r>
+            <a:r>
+              <a:rPr kumimoji="1" lang="en" altLang="zh-CN" dirty="0"/>
+              <a:t> Struct_expr_1 }</a:t>
+            </a:r>
+          </a:p>
+          <a:p>
+            <a:r>
+              <a:rPr kumimoji="1" lang="en" altLang="zh-CN" dirty="0"/>
+              <a:t>Struct_expr_1 ::= , </a:t>
+            </a:r>
+            <a:r>
+              <a:rPr kumimoji="1" lang="en" altLang="zh-CN" dirty="0" err="1"/>
+              <a:t>Label_expr</a:t>
+            </a:r>
+            <a:r>
+              <a:rPr kumimoji="1" lang="en" altLang="zh-CN" dirty="0"/>
+              <a:t> Struct_expr_1</a:t>
+            </a:r>
+          </a:p>
+          <a:p>
+            <a:r>
+              <a:rPr kumimoji="1" lang="en" altLang="zh-CN" dirty="0"/>
+              <a:t>                      ::= $</a:t>
+            </a:r>
+          </a:p>
+          <a:p>
+            <a:r>
+              <a:rPr kumimoji="1" lang="en" altLang="zh-CN" dirty="0" err="1"/>
+              <a:t>Label_expr</a:t>
+            </a:r>
+            <a:r>
+              <a:rPr kumimoji="1" lang="en" altLang="zh-CN" dirty="0"/>
+              <a:t> ::= id : Expr</a:t>
+            </a:r>
+            <a:endParaRPr kumimoji="1" lang="zh-CN" altLang="en-US" dirty="0"/>
+          </a:p>
+        </p:txBody>
+      </p:sp>
+      <p:sp>
+        <p:nvSpPr>
+          <p:cNvPr id="2" name="文本框 1">
+            <a:extLst>
+              <a:ext uri="{FF2B5EF4-FFF2-40B4-BE49-F238E27FC236}">
+                <a16:creationId xmlns:a16="http://schemas.microsoft.com/office/drawing/2014/main" id="{9677685D-F885-4F12-BF43-DDE8CF0D1C0E}"/>
+              </a:ext>
+            </a:extLst>
+          </p:cNvPr>
+          <p:cNvSpPr txBox="1"/>
+          <p:nvPr/>
+        </p:nvSpPr>
+        <p:spPr>
+          <a:xfrm>
+            <a:off x="308472" y="2510642"/>
+            <a:ext cx="5930284" cy="369332"/>
+          </a:xfrm>
+          <a:prstGeom prst="rect">
+            <a:avLst/>
+          </a:prstGeom>
+          <a:noFill/>
+        </p:spPr>
+        <p:txBody>
+          <a:bodyPr wrap="square" rtlCol="0">
+            <a:spAutoFit/>
+          </a:bodyPr>
+          <a:lstStyle/>
+          <a:p>
+            <a:r>
+              <a:rPr lang="en" altLang="zh-CN"/>
+              <a:t>const c7:t2={tt1:false,tt2:8,tt3:0.2}; </a:t>
+            </a:r>
+          </a:p>
+        </p:txBody>
+      </p:sp>
+      <p:sp>
+        <p:nvSpPr>
+          <p:cNvPr id="3" name="文本框 2">
+            <a:extLst>
+              <a:ext uri="{FF2B5EF4-FFF2-40B4-BE49-F238E27FC236}">
+                <a16:creationId xmlns:a16="http://schemas.microsoft.com/office/drawing/2014/main" id="{0EDC0587-5B7C-42E2-B2EA-7E6AF9FFF17F}"/>
+              </a:ext>
+            </a:extLst>
+          </p:cNvPr>
+          <p:cNvSpPr txBox="1"/>
+          <p:nvPr/>
+        </p:nvSpPr>
+        <p:spPr>
+          <a:xfrm>
+            <a:off x="399495" y="1864311"/>
+            <a:ext cx="3773010" cy="646331"/>
+          </a:xfrm>
+          <a:prstGeom prst="rect">
+            <a:avLst/>
+          </a:prstGeom>
+          <a:noFill/>
+        </p:spPr>
+        <p:txBody>
+          <a:bodyPr wrap="square" rtlCol="0">
+            <a:spAutoFit/>
+          </a:bodyPr>
+          <a:lstStyle/>
+          <a:p>
+            <a:r>
+              <a:rPr lang="en-US" altLang="zh-CN" b="1"/>
+              <a:t>const</a:t>
+            </a:r>
+            <a:r>
+              <a:rPr lang="zh-CN" altLang="en-US" b="1"/>
+              <a:t>初始化</a:t>
+            </a:r>
+            <a:endParaRPr lang="en-US" altLang="zh-CN" b="1"/>
+          </a:p>
+          <a:p>
+            <a:r>
+              <a:rPr lang="en-US" altLang="zh-CN"/>
+              <a:t>Scade</a:t>
+            </a:r>
+            <a:r>
+              <a:rPr lang="zh-CN" altLang="en-US"/>
+              <a:t>程序</a:t>
+            </a:r>
+          </a:p>
+        </p:txBody>
+      </p:sp>
+      <p:sp>
+        <p:nvSpPr>
+          <p:cNvPr id="5" name="文本框 4">
+            <a:extLst>
+              <a:ext uri="{FF2B5EF4-FFF2-40B4-BE49-F238E27FC236}">
+                <a16:creationId xmlns:a16="http://schemas.microsoft.com/office/drawing/2014/main" id="{5E00975D-BC29-478A-8EE4-7A8B5B1DDAAD}"/>
+              </a:ext>
+            </a:extLst>
+          </p:cNvPr>
+          <p:cNvSpPr txBox="1"/>
+          <p:nvPr/>
+        </p:nvSpPr>
+        <p:spPr>
+          <a:xfrm>
+            <a:off x="399495" y="2947387"/>
+            <a:ext cx="4154750" cy="646331"/>
+          </a:xfrm>
+          <a:prstGeom prst="rect">
+            <a:avLst/>
+          </a:prstGeom>
+          <a:noFill/>
+        </p:spPr>
+        <p:txBody>
+          <a:bodyPr wrap="square" rtlCol="0">
+            <a:spAutoFit/>
+          </a:bodyPr>
+          <a:lstStyle/>
+          <a:p>
+            <a:r>
+              <a:rPr lang="zh-CN" altLang="en-US"/>
+              <a:t>转化后</a:t>
+            </a:r>
+            <a:r>
+              <a:rPr lang="en-US" altLang="zh-CN"/>
+              <a:t>C</a:t>
+            </a:r>
+            <a:r>
+              <a:rPr lang="zh-CN" altLang="en-US"/>
+              <a:t>程序</a:t>
+            </a:r>
+            <a:endParaRPr lang="en" altLang="zh-CN"/>
+          </a:p>
+          <a:p>
+            <a:r>
+              <a:rPr lang="en" altLang="zh-CN"/>
+              <a:t>extern const t2 c7 = {false,8,0.2};</a:t>
+            </a:r>
+            <a:endParaRPr kumimoji="1" lang="en-US" altLang="zh-CN"/>
+          </a:p>
+        </p:txBody>
+      </p:sp>
+    </p:spTree>
+    <p:extLst>
+      <p:ext uri="{BB962C8B-B14F-4D97-AF65-F5344CB8AC3E}">
+        <p14:creationId xmlns:p14="http://schemas.microsoft.com/office/powerpoint/2010/main" val="3818820110"/>
+      </p:ext>
+    </p:extLst>
+  </p:cSld>
+  <p:clrMapOvr>
+    <a:masterClrMapping/>
+  </p:clrMapOvr>
+</p:sld>
+</file>
+
+<file path=ppt/slides/slide32.xml><?xml version="1.0" encoding="utf-8"?>
+<p:sld xmlns:a="http://schemas.openxmlformats.org/drawingml/2006/main" xmlns:r="http://schemas.openxmlformats.org/officeDocument/2006/relationships" xmlns:p="http://schemas.openxmlformats.org/presentationml/2006/main">
+  <p:cSld>
+    <p:spTree>
+      <p:nvGrpSpPr>
+        <p:cNvPr id="1" name=""/>
+        <p:cNvGrpSpPr/>
+        <p:nvPr/>
+      </p:nvGrpSpPr>
+      <p:grpSpPr>
+        <a:xfrm>
+          <a:off x="0" y="0"/>
+          <a:ext cx="0" cy="0"/>
+          <a:chOff x="0" y="0"/>
+          <a:chExt cx="0" cy="0"/>
+        </a:xfrm>
+      </p:grpSpPr>
+      <p:sp>
+        <p:nvSpPr>
+          <p:cNvPr id="4" name="文本框 3">
+            <a:extLst>
+              <a:ext uri="{FF2B5EF4-FFF2-40B4-BE49-F238E27FC236}">
+                <a16:creationId xmlns:a16="http://schemas.microsoft.com/office/drawing/2014/main" id="{DBFFF9E3-BC37-4E28-8C8B-8277630EC54A}"/>
+              </a:ext>
+            </a:extLst>
+          </p:cNvPr>
+          <p:cNvSpPr txBox="1"/>
+          <p:nvPr/>
+        </p:nvSpPr>
+        <p:spPr>
+          <a:xfrm>
+            <a:off x="0" y="7820"/>
+            <a:ext cx="4296792" cy="369332"/>
+          </a:xfrm>
+          <a:prstGeom prst="rect">
+            <a:avLst/>
+          </a:prstGeom>
+          <a:noFill/>
+        </p:spPr>
+        <p:txBody>
+          <a:bodyPr wrap="square" rtlCol="0">
+            <a:spAutoFit/>
+          </a:bodyPr>
+          <a:lstStyle/>
+          <a:p>
+            <a:r>
+              <a:rPr lang="zh-CN" altLang="en-US" b="1"/>
+              <a:t>未添加的文法</a:t>
+            </a:r>
+          </a:p>
+        </p:txBody>
+      </p:sp>
       <p:pic>
         <p:nvPicPr>
-          <p:cNvPr id="4" name="图片 3">
-            <a:extLst>
-              <a:ext uri="{FF2B5EF4-FFF2-40B4-BE49-F238E27FC236}">
-                <a16:creationId xmlns:a16="http://schemas.microsoft.com/office/drawing/2014/main" id="{615242F5-0EAE-4DB8-B29E-B2AB2941BD50}"/>
+          <p:cNvPr id="5" name="图片 4">
+            <a:extLst>
+              <a:ext uri="{FF2B5EF4-FFF2-40B4-BE49-F238E27FC236}">
+                <a16:creationId xmlns:a16="http://schemas.microsoft.com/office/drawing/2014/main" id="{56F0CC9D-E49A-41E7-B339-CCE8F7D9AD1F}"/>
               </a:ext>
             </a:extLst>
           </p:cNvPr>
@@ -8472,20 +9644,170 @@
         </p:blipFill>
         <p:spPr>
           <a:xfrm>
-            <a:off x="204721" y="273379"/>
-            <a:ext cx="5585944" cy="3772227"/>
+            <a:off x="266330" y="703099"/>
+            <a:ext cx="5410669" cy="1265030"/>
           </a:xfrm>
           <a:prstGeom prst="rect">
             <a:avLst/>
           </a:prstGeom>
         </p:spPr>
       </p:pic>
+      <p:sp>
+        <p:nvSpPr>
+          <p:cNvPr id="9" name="文本框 8">
+            <a:extLst>
+              <a:ext uri="{FF2B5EF4-FFF2-40B4-BE49-F238E27FC236}">
+                <a16:creationId xmlns:a16="http://schemas.microsoft.com/office/drawing/2014/main" id="{BAD52B07-C55C-4753-B484-99D9AE259239}"/>
+              </a:ext>
+            </a:extLst>
+          </p:cNvPr>
+          <p:cNvSpPr txBox="1"/>
+          <p:nvPr/>
+        </p:nvSpPr>
+        <p:spPr>
+          <a:xfrm>
+            <a:off x="159799" y="2254928"/>
+            <a:ext cx="9401452" cy="5355312"/>
+          </a:xfrm>
+          <a:prstGeom prst="rect">
+            <a:avLst/>
+          </a:prstGeom>
+          <a:noFill/>
+        </p:spPr>
+        <p:txBody>
+          <a:bodyPr wrap="square" rtlCol="0">
+            <a:spAutoFit/>
+          </a:bodyPr>
+          <a:lstStyle/>
+          <a:p>
+            <a:r>
+              <a:rPr lang="en-US" altLang="zh-CN"/>
+              <a:t>Params ::= ( Params_1 )</a:t>
+            </a:r>
+            <a:br>
+              <a:rPr lang="en-US" altLang="zh-CN"/>
+            </a:br>
+            <a:r>
+              <a:rPr lang="en-US" altLang="zh-CN"/>
+              <a:t>Params_1 ::= Var_decls Params_2</a:t>
+            </a:r>
+            <a:br>
+              <a:rPr lang="en-US" altLang="zh-CN"/>
+            </a:br>
+            <a:r>
+              <a:rPr lang="en-US" altLang="zh-CN"/>
+              <a:t>          	::= $</a:t>
+            </a:r>
+            <a:br>
+              <a:rPr lang="en-US" altLang="zh-CN"/>
+            </a:br>
+            <a:r>
+              <a:rPr lang="en-US" altLang="zh-CN"/>
+              <a:t>Params_2 ::= ; Var_decls Params_2</a:t>
+            </a:r>
+            <a:br>
+              <a:rPr lang="en-US" altLang="zh-CN"/>
+            </a:br>
+            <a:r>
+              <a:rPr lang="en-US" altLang="zh-CN"/>
+              <a:t>          	::= $</a:t>
+            </a:r>
+          </a:p>
+          <a:p>
+            <a:r>
+              <a:rPr lang="en-US" altLang="zh-CN"/>
+              <a:t>Var_decls ::= Var_id Var_decls_1 : Type_expr Var_decls_2 </a:t>
+            </a:r>
+          </a:p>
+          <a:p>
+            <a:r>
+              <a:rPr lang="en-US" altLang="zh-CN"/>
+              <a:t>	       Var_decls_3 Var_decls_4</a:t>
+            </a:r>
+            <a:br>
+              <a:rPr lang="en-US" altLang="zh-CN"/>
+            </a:br>
+            <a:r>
+              <a:rPr lang="en-US" altLang="zh-CN"/>
+              <a:t>Var_decls_1 ::= , Var_id Var_decls_1</a:t>
+            </a:r>
+            <a:br>
+              <a:rPr lang="en-US" altLang="zh-CN"/>
+            </a:br>
+            <a:r>
+              <a:rPr lang="en-US" altLang="zh-CN"/>
+              <a:t>             ::= $</a:t>
+            </a:r>
+            <a:br>
+              <a:rPr lang="en-US" altLang="zh-CN"/>
+            </a:br>
+            <a:r>
+              <a:rPr lang="en-US" altLang="zh-CN"/>
+              <a:t>Var_decls_2 ::= When_decl</a:t>
+            </a:r>
+            <a:br>
+              <a:rPr lang="en-US" altLang="zh-CN"/>
+            </a:br>
+            <a:r>
+              <a:rPr lang="en-US" altLang="zh-CN"/>
+              <a:t>             ::= $</a:t>
+            </a:r>
+            <a:br>
+              <a:rPr lang="en-US" altLang="zh-CN"/>
+            </a:br>
+            <a:r>
+              <a:rPr lang="en-US" altLang="zh-CN"/>
+              <a:t>Var_decls_3 ::= Default_decl</a:t>
+            </a:r>
+            <a:br>
+              <a:rPr lang="en-US" altLang="zh-CN"/>
+            </a:br>
+            <a:r>
+              <a:rPr lang="en-US" altLang="zh-CN"/>
+              <a:t>             ::= $</a:t>
+            </a:r>
+            <a:br>
+              <a:rPr lang="en-US" altLang="zh-CN"/>
+            </a:br>
+            <a:r>
+              <a:rPr lang="en-US" altLang="zh-CN"/>
+              <a:t>Var_decls_4 ::= Last_decl</a:t>
+            </a:r>
+            <a:br>
+              <a:rPr lang="en-US" altLang="zh-CN"/>
+            </a:br>
+            <a:r>
+              <a:rPr lang="en-US" altLang="zh-CN"/>
+              <a:t>             ::= $</a:t>
+            </a:r>
+          </a:p>
+          <a:p>
+            <a:r>
+              <a:rPr lang="en-US" altLang="zh-CN" b="1">
+                <a:solidFill>
+                  <a:srgbClr val="FF0000"/>
+                </a:solidFill>
+              </a:rPr>
+              <a:t>Last_decl ::= last = Expr</a:t>
+            </a:r>
+          </a:p>
+          <a:p>
+            <a:endParaRPr lang="en-US" altLang="zh-CN"/>
+          </a:p>
+          <a:p>
+            <a:endParaRPr lang="en-US" altLang="zh-CN"/>
+          </a:p>
+          <a:p>
+            <a:endParaRPr lang="zh-CN" altLang="en-US"/>
+          </a:p>
+        </p:txBody>
+      </p:sp>
       <p:pic>
         <p:nvPicPr>
-          <p:cNvPr id="5" name="图片 4">
-            <a:extLst>
-              <a:ext uri="{FF2B5EF4-FFF2-40B4-BE49-F238E27FC236}">
-                <a16:creationId xmlns:a16="http://schemas.microsoft.com/office/drawing/2014/main" id="{765CBF09-7F91-425D-AFC5-6DA3E2E5ABF8}"/>
+          <p:cNvPr id="10" name="图片 9">
+            <a:extLst>
+              <a:ext uri="{FF2B5EF4-FFF2-40B4-BE49-F238E27FC236}">
+                <a16:creationId xmlns:a16="http://schemas.microsoft.com/office/drawing/2014/main" id="{49819853-7079-4370-BA2D-6FAF3799EF7F}"/>
               </a:ext>
             </a:extLst>
           </p:cNvPr>
@@ -8502,18 +9824,677 @@
         </p:blipFill>
         <p:spPr>
           <a:xfrm>
-            <a:off x="6096000" y="143474"/>
-            <a:ext cx="5502117" cy="6233700"/>
+            <a:off x="6810321" y="880707"/>
+            <a:ext cx="4671465" cy="5639289"/>
           </a:xfrm>
           <a:prstGeom prst="rect">
             <a:avLst/>
           </a:prstGeom>
         </p:spPr>
       </p:pic>
+      <p:sp>
+        <p:nvSpPr>
+          <p:cNvPr id="11" name="文本框 10">
+            <a:extLst>
+              <a:ext uri="{FF2B5EF4-FFF2-40B4-BE49-F238E27FC236}">
+                <a16:creationId xmlns:a16="http://schemas.microsoft.com/office/drawing/2014/main" id="{8D493EE6-A6E6-45D0-88BA-FD0458E05BBB}"/>
+              </a:ext>
+            </a:extLst>
+          </p:cNvPr>
+          <p:cNvSpPr txBox="1"/>
+          <p:nvPr/>
+        </p:nvSpPr>
+        <p:spPr>
+          <a:xfrm>
+            <a:off x="266330" y="333767"/>
+            <a:ext cx="2246051" cy="369332"/>
+          </a:xfrm>
+          <a:prstGeom prst="rect">
+            <a:avLst/>
+          </a:prstGeom>
+          <a:noFill/>
+        </p:spPr>
+        <p:txBody>
+          <a:bodyPr wrap="square" rtlCol="0">
+            <a:spAutoFit/>
+          </a:bodyPr>
+          <a:lstStyle/>
+          <a:p>
+            <a:r>
+              <a:rPr lang="en-US" altLang="zh-CN"/>
+              <a:t>Scade</a:t>
+            </a:r>
+            <a:r>
+              <a:rPr lang="zh-CN" altLang="en-US"/>
+              <a:t>程序</a:t>
+            </a:r>
+          </a:p>
+        </p:txBody>
+      </p:sp>
+      <p:sp>
+        <p:nvSpPr>
+          <p:cNvPr id="12" name="文本框 11">
+            <a:extLst>
+              <a:ext uri="{FF2B5EF4-FFF2-40B4-BE49-F238E27FC236}">
+                <a16:creationId xmlns:a16="http://schemas.microsoft.com/office/drawing/2014/main" id="{82F70CD5-5FD4-458F-8FE7-D71A44454A7C}"/>
+              </a:ext>
+            </a:extLst>
+          </p:cNvPr>
+          <p:cNvSpPr txBox="1"/>
+          <p:nvPr/>
+        </p:nvSpPr>
+        <p:spPr>
+          <a:xfrm>
+            <a:off x="6810321" y="338004"/>
+            <a:ext cx="2246051" cy="369332"/>
+          </a:xfrm>
+          <a:prstGeom prst="rect">
+            <a:avLst/>
+          </a:prstGeom>
+          <a:noFill/>
+        </p:spPr>
+        <p:txBody>
+          <a:bodyPr wrap="square" rtlCol="0">
+            <a:spAutoFit/>
+          </a:bodyPr>
+          <a:lstStyle/>
+          <a:p>
+            <a:r>
+              <a:rPr lang="zh-CN" altLang="en-US"/>
+              <a:t>转化后的</a:t>
+            </a:r>
+            <a:r>
+              <a:rPr lang="en-US" altLang="zh-CN"/>
+              <a:t>C</a:t>
+            </a:r>
+            <a:r>
+              <a:rPr lang="zh-CN" altLang="en-US"/>
+              <a:t>程序</a:t>
+            </a:r>
+          </a:p>
+        </p:txBody>
+      </p:sp>
+      <p:sp>
+        <p:nvSpPr>
+          <p:cNvPr id="13" name="文本框 12">
+            <a:extLst>
+              <a:ext uri="{FF2B5EF4-FFF2-40B4-BE49-F238E27FC236}">
+                <a16:creationId xmlns:a16="http://schemas.microsoft.com/office/drawing/2014/main" id="{DB74BDED-88A2-4A9F-9669-25E342E12837}"/>
+              </a:ext>
+            </a:extLst>
+          </p:cNvPr>
+          <p:cNvSpPr txBox="1"/>
+          <p:nvPr/>
+        </p:nvSpPr>
+        <p:spPr>
+          <a:xfrm>
+            <a:off x="159799" y="1968129"/>
+            <a:ext cx="2246051" cy="369332"/>
+          </a:xfrm>
+          <a:prstGeom prst="rect">
+            <a:avLst/>
+          </a:prstGeom>
+          <a:noFill/>
+        </p:spPr>
+        <p:txBody>
+          <a:bodyPr wrap="square" rtlCol="0">
+            <a:spAutoFit/>
+          </a:bodyPr>
+          <a:lstStyle/>
+          <a:p>
+            <a:r>
+              <a:rPr lang="en-US" altLang="zh-CN" b="1"/>
+              <a:t>Scade</a:t>
+            </a:r>
+            <a:r>
+              <a:rPr lang="zh-CN" altLang="en-US" b="1"/>
+              <a:t>对应的文法</a:t>
+            </a:r>
+          </a:p>
+        </p:txBody>
+      </p:sp>
     </p:spTree>
     <p:extLst>
       <p:ext uri="{BB962C8B-B14F-4D97-AF65-F5344CB8AC3E}">
-        <p14:creationId xmlns:p14="http://schemas.microsoft.com/office/powerpoint/2010/main" val="963582803"/>
+        <p14:creationId xmlns:p14="http://schemas.microsoft.com/office/powerpoint/2010/main" val="2412528168"/>
+      </p:ext>
+    </p:extLst>
+  </p:cSld>
+  <p:clrMapOvr>
+    <a:masterClrMapping/>
+  </p:clrMapOvr>
+</p:sld>
+</file>
+
+<file path=ppt/slides/slide33.xml><?xml version="1.0" encoding="utf-8"?>
+<p:sld xmlns:a="http://schemas.openxmlformats.org/drawingml/2006/main" xmlns:r="http://schemas.openxmlformats.org/officeDocument/2006/relationships" xmlns:p="http://schemas.openxmlformats.org/presentationml/2006/main">
+  <p:cSld>
+    <p:spTree>
+      <p:nvGrpSpPr>
+        <p:cNvPr id="1" name=""/>
+        <p:cNvGrpSpPr/>
+        <p:nvPr/>
+      </p:nvGrpSpPr>
+      <p:grpSpPr>
+        <a:xfrm>
+          <a:off x="0" y="0"/>
+          <a:ext cx="0" cy="0"/>
+          <a:chOff x="0" y="0"/>
+          <a:chExt cx="0" cy="0"/>
+        </a:xfrm>
+      </p:grpSpPr>
+      <p:pic>
+        <p:nvPicPr>
+          <p:cNvPr id="4" name="图片 3">
+            <a:extLst>
+              <a:ext uri="{FF2B5EF4-FFF2-40B4-BE49-F238E27FC236}">
+                <a16:creationId xmlns:a16="http://schemas.microsoft.com/office/drawing/2014/main" id="{E8C0155E-3684-4970-BCC2-2179DDF32436}"/>
+              </a:ext>
+            </a:extLst>
+          </p:cNvPr>
+          <p:cNvPicPr>
+            <a:picLocks noChangeAspect="1"/>
+          </p:cNvPicPr>
+          <p:nvPr/>
+        </p:nvPicPr>
+        <p:blipFill>
+          <a:blip r:embed="rId2"/>
+          <a:stretch>
+            <a:fillRect/>
+          </a:stretch>
+        </p:blipFill>
+        <p:spPr>
+          <a:xfrm>
+            <a:off x="204995" y="675097"/>
+            <a:ext cx="5601001" cy="3093988"/>
+          </a:xfrm>
+          <a:prstGeom prst="rect">
+            <a:avLst/>
+          </a:prstGeom>
+        </p:spPr>
+      </p:pic>
+      <p:sp>
+        <p:nvSpPr>
+          <p:cNvPr id="5" name="文本框 4">
+            <a:extLst>
+              <a:ext uri="{FF2B5EF4-FFF2-40B4-BE49-F238E27FC236}">
+                <a16:creationId xmlns:a16="http://schemas.microsoft.com/office/drawing/2014/main" id="{37B711BD-C297-422E-848A-8FB2D0D01837}"/>
+              </a:ext>
+            </a:extLst>
+          </p:cNvPr>
+          <p:cNvSpPr txBox="1"/>
+          <p:nvPr/>
+        </p:nvSpPr>
+        <p:spPr>
+          <a:xfrm>
+            <a:off x="329283" y="4820575"/>
+            <a:ext cx="3381584" cy="1200329"/>
+          </a:xfrm>
+          <a:prstGeom prst="rect">
+            <a:avLst/>
+          </a:prstGeom>
+          <a:noFill/>
+        </p:spPr>
+        <p:txBody>
+          <a:bodyPr wrap="square" rtlCol="0">
+            <a:spAutoFit/>
+          </a:bodyPr>
+          <a:lstStyle/>
+          <a:p>
+            <a:r>
+              <a:rPr lang="en-US" altLang="zh-CN"/>
+              <a:t>Expr ::= Id_expr</a:t>
+            </a:r>
+          </a:p>
+          <a:p>
+            <a:r>
+              <a:rPr lang="en-US" altLang="zh-CN"/>
+              <a:t>Id_expr ::= Path_id</a:t>
+            </a:r>
+            <a:br>
+              <a:rPr lang="en-US" altLang="zh-CN"/>
+            </a:br>
+            <a:r>
+              <a:rPr lang="en-US" altLang="zh-CN"/>
+              <a:t>         ::= name</a:t>
+            </a:r>
+            <a:br>
+              <a:rPr lang="en-US" altLang="zh-CN"/>
+            </a:br>
+            <a:r>
+              <a:rPr lang="en-US" altLang="zh-CN"/>
+              <a:t>         ::= </a:t>
+            </a:r>
+            <a:r>
+              <a:rPr lang="en-US" altLang="zh-CN" b="1">
+                <a:solidFill>
+                  <a:srgbClr val="FF0000"/>
+                </a:solidFill>
+              </a:rPr>
+              <a:t>last name</a:t>
+            </a:r>
+          </a:p>
+        </p:txBody>
+      </p:sp>
+      <p:pic>
+        <p:nvPicPr>
+          <p:cNvPr id="6" name="图片 5">
+            <a:extLst>
+              <a:ext uri="{FF2B5EF4-FFF2-40B4-BE49-F238E27FC236}">
+                <a16:creationId xmlns:a16="http://schemas.microsoft.com/office/drawing/2014/main" id="{FB0C2B3E-589C-4365-9375-C3E6D1C5BC17}"/>
+              </a:ext>
+            </a:extLst>
+          </p:cNvPr>
+          <p:cNvPicPr>
+            <a:picLocks noChangeAspect="1"/>
+          </p:cNvPicPr>
+          <p:nvPr/>
+        </p:nvPicPr>
+        <p:blipFill>
+          <a:blip r:embed="rId3"/>
+          <a:stretch>
+            <a:fillRect/>
+          </a:stretch>
+        </p:blipFill>
+        <p:spPr>
+          <a:xfrm>
+            <a:off x="5894773" y="819889"/>
+            <a:ext cx="6165114" cy="5898391"/>
+          </a:xfrm>
+          <a:prstGeom prst="rect">
+            <a:avLst/>
+          </a:prstGeom>
+        </p:spPr>
+      </p:pic>
+      <p:sp>
+        <p:nvSpPr>
+          <p:cNvPr id="7" name="文本框 6">
+            <a:extLst>
+              <a:ext uri="{FF2B5EF4-FFF2-40B4-BE49-F238E27FC236}">
+                <a16:creationId xmlns:a16="http://schemas.microsoft.com/office/drawing/2014/main" id="{77AD7516-2341-4941-839F-A19A9D3C6C09}"/>
+              </a:ext>
+            </a:extLst>
+          </p:cNvPr>
+          <p:cNvSpPr txBox="1"/>
+          <p:nvPr/>
+        </p:nvSpPr>
+        <p:spPr>
+          <a:xfrm>
+            <a:off x="329283" y="4451243"/>
+            <a:ext cx="2246051" cy="369332"/>
+          </a:xfrm>
+          <a:prstGeom prst="rect">
+            <a:avLst/>
+          </a:prstGeom>
+          <a:noFill/>
+        </p:spPr>
+        <p:txBody>
+          <a:bodyPr wrap="square" rtlCol="0">
+            <a:spAutoFit/>
+          </a:bodyPr>
+          <a:lstStyle/>
+          <a:p>
+            <a:r>
+              <a:rPr lang="en-US" altLang="zh-CN" b="1"/>
+              <a:t>Scade</a:t>
+            </a:r>
+            <a:r>
+              <a:rPr lang="zh-CN" altLang="en-US" b="1"/>
+              <a:t>对应的文法</a:t>
+            </a:r>
+          </a:p>
+        </p:txBody>
+      </p:sp>
+      <p:sp>
+        <p:nvSpPr>
+          <p:cNvPr id="8" name="文本框 7">
+            <a:extLst>
+              <a:ext uri="{FF2B5EF4-FFF2-40B4-BE49-F238E27FC236}">
+                <a16:creationId xmlns:a16="http://schemas.microsoft.com/office/drawing/2014/main" id="{4FAB46DB-2FC9-425B-A11D-FA601EF284B1}"/>
+              </a:ext>
+            </a:extLst>
+          </p:cNvPr>
+          <p:cNvSpPr txBox="1"/>
+          <p:nvPr/>
+        </p:nvSpPr>
+        <p:spPr>
+          <a:xfrm>
+            <a:off x="204995" y="305765"/>
+            <a:ext cx="2246051" cy="369332"/>
+          </a:xfrm>
+          <a:prstGeom prst="rect">
+            <a:avLst/>
+          </a:prstGeom>
+          <a:noFill/>
+        </p:spPr>
+        <p:txBody>
+          <a:bodyPr wrap="square" rtlCol="0">
+            <a:spAutoFit/>
+          </a:bodyPr>
+          <a:lstStyle/>
+          <a:p>
+            <a:r>
+              <a:rPr lang="en-US" altLang="zh-CN" b="1"/>
+              <a:t>Scade</a:t>
+            </a:r>
+            <a:r>
+              <a:rPr lang="zh-CN" altLang="en-US" b="1"/>
+              <a:t>程序</a:t>
+            </a:r>
+          </a:p>
+        </p:txBody>
+      </p:sp>
+      <p:sp>
+        <p:nvSpPr>
+          <p:cNvPr id="9" name="文本框 8">
+            <a:extLst>
+              <a:ext uri="{FF2B5EF4-FFF2-40B4-BE49-F238E27FC236}">
+                <a16:creationId xmlns:a16="http://schemas.microsoft.com/office/drawing/2014/main" id="{33742FEF-16B7-4F2D-A9D6-99DC55FC8153}"/>
+              </a:ext>
+            </a:extLst>
+          </p:cNvPr>
+          <p:cNvSpPr txBox="1"/>
+          <p:nvPr/>
+        </p:nvSpPr>
+        <p:spPr>
+          <a:xfrm>
+            <a:off x="5894773" y="305765"/>
+            <a:ext cx="2246051" cy="369332"/>
+          </a:xfrm>
+          <a:prstGeom prst="rect">
+            <a:avLst/>
+          </a:prstGeom>
+          <a:noFill/>
+        </p:spPr>
+        <p:txBody>
+          <a:bodyPr wrap="square" rtlCol="0">
+            <a:spAutoFit/>
+          </a:bodyPr>
+          <a:lstStyle/>
+          <a:p>
+            <a:r>
+              <a:rPr lang="zh-CN" altLang="en-US" b="1"/>
+              <a:t>转化后的</a:t>
+            </a:r>
+            <a:r>
+              <a:rPr lang="en-US" altLang="zh-CN" b="1"/>
+              <a:t>C</a:t>
+            </a:r>
+            <a:r>
+              <a:rPr lang="zh-CN" altLang="en-US" b="1"/>
+              <a:t>程序</a:t>
+            </a:r>
+          </a:p>
+        </p:txBody>
+      </p:sp>
+    </p:spTree>
+    <p:extLst>
+      <p:ext uri="{BB962C8B-B14F-4D97-AF65-F5344CB8AC3E}">
+        <p14:creationId xmlns:p14="http://schemas.microsoft.com/office/powerpoint/2010/main" val="3772738537"/>
+      </p:ext>
+    </p:extLst>
+  </p:cSld>
+  <p:clrMapOvr>
+    <a:masterClrMapping/>
+  </p:clrMapOvr>
+</p:sld>
+</file>
+
+<file path=ppt/slides/slide34.xml><?xml version="1.0" encoding="utf-8"?>
+<p:sld xmlns:a="http://schemas.openxmlformats.org/drawingml/2006/main" xmlns:r="http://schemas.openxmlformats.org/officeDocument/2006/relationships" xmlns:p="http://schemas.openxmlformats.org/presentationml/2006/main">
+  <p:cSld>
+    <p:spTree>
+      <p:nvGrpSpPr>
+        <p:cNvPr id="1" name=""/>
+        <p:cNvGrpSpPr/>
+        <p:nvPr/>
+      </p:nvGrpSpPr>
+      <p:grpSpPr>
+        <a:xfrm>
+          <a:off x="0" y="0"/>
+          <a:ext cx="0" cy="0"/>
+          <a:chOff x="0" y="0"/>
+          <a:chExt cx="0" cy="0"/>
+        </a:xfrm>
+      </p:grpSpPr>
+      <p:pic>
+        <p:nvPicPr>
+          <p:cNvPr id="4" name="图片 3">
+            <a:extLst>
+              <a:ext uri="{FF2B5EF4-FFF2-40B4-BE49-F238E27FC236}">
+                <a16:creationId xmlns:a16="http://schemas.microsoft.com/office/drawing/2014/main" id="{2AD2EB48-CAE0-45C1-98BC-E5FD1AF535E4}"/>
+              </a:ext>
+            </a:extLst>
+          </p:cNvPr>
+          <p:cNvPicPr>
+            <a:picLocks noChangeAspect="1"/>
+          </p:cNvPicPr>
+          <p:nvPr/>
+        </p:nvPicPr>
+        <p:blipFill>
+          <a:blip r:embed="rId2"/>
+          <a:stretch>
+            <a:fillRect/>
+          </a:stretch>
+        </p:blipFill>
+        <p:spPr>
+          <a:xfrm>
+            <a:off x="319581" y="867534"/>
+            <a:ext cx="4610500" cy="2286198"/>
+          </a:xfrm>
+          <a:prstGeom prst="rect">
+            <a:avLst/>
+          </a:prstGeom>
+        </p:spPr>
+      </p:pic>
+      <p:sp>
+        <p:nvSpPr>
+          <p:cNvPr id="6" name="文本框 5">
+            <a:extLst>
+              <a:ext uri="{FF2B5EF4-FFF2-40B4-BE49-F238E27FC236}">
+                <a16:creationId xmlns:a16="http://schemas.microsoft.com/office/drawing/2014/main" id="{AB557F75-5F2C-4A63-8663-B8434B4D6423}"/>
+              </a:ext>
+            </a:extLst>
+          </p:cNvPr>
+          <p:cNvSpPr txBox="1"/>
+          <p:nvPr/>
+        </p:nvSpPr>
+        <p:spPr>
+          <a:xfrm>
+            <a:off x="319581" y="4455738"/>
+            <a:ext cx="3906190" cy="923330"/>
+          </a:xfrm>
+          <a:prstGeom prst="rect">
+            <a:avLst/>
+          </a:prstGeom>
+          <a:noFill/>
+        </p:spPr>
+        <p:txBody>
+          <a:bodyPr wrap="square" rtlCol="0">
+            <a:spAutoFit/>
+          </a:bodyPr>
+          <a:lstStyle/>
+          <a:p>
+            <a:r>
+              <a:rPr lang="en-US" altLang="zh-CN"/>
+              <a:t>Arith_expr ::= Unary_arith_op Expr</a:t>
+            </a:r>
+            <a:br>
+              <a:rPr lang="en-US" altLang="zh-CN"/>
+            </a:br>
+            <a:r>
+              <a:rPr lang="en-US" altLang="zh-CN"/>
+              <a:t>            ::= Expr Bin_arith_op Expr</a:t>
+            </a:r>
+            <a:br>
+              <a:rPr lang="en-US" altLang="zh-CN"/>
+            </a:br>
+            <a:r>
+              <a:rPr lang="en-US" altLang="zh-CN"/>
+              <a:t>            ::= ( Expr : Type_expr )</a:t>
+            </a:r>
+          </a:p>
+        </p:txBody>
+      </p:sp>
+      <p:pic>
+        <p:nvPicPr>
+          <p:cNvPr id="7" name="图片 6">
+            <a:extLst>
+              <a:ext uri="{FF2B5EF4-FFF2-40B4-BE49-F238E27FC236}">
+                <a16:creationId xmlns:a16="http://schemas.microsoft.com/office/drawing/2014/main" id="{F883907C-6C52-4C57-AA96-7A7E92ACF678}"/>
+              </a:ext>
+            </a:extLst>
+          </p:cNvPr>
+          <p:cNvPicPr>
+            <a:picLocks noChangeAspect="1"/>
+          </p:cNvPicPr>
+          <p:nvPr/>
+        </p:nvPicPr>
+        <p:blipFill>
+          <a:blip r:embed="rId3"/>
+          <a:stretch>
+            <a:fillRect/>
+          </a:stretch>
+        </p:blipFill>
+        <p:spPr>
+          <a:xfrm>
+            <a:off x="5398904" y="867534"/>
+            <a:ext cx="6294665" cy="960203"/>
+          </a:xfrm>
+          <a:prstGeom prst="rect">
+            <a:avLst/>
+          </a:prstGeom>
+        </p:spPr>
+      </p:pic>
+      <p:sp>
+        <p:nvSpPr>
+          <p:cNvPr id="8" name="文本框 7">
+            <a:extLst>
+              <a:ext uri="{FF2B5EF4-FFF2-40B4-BE49-F238E27FC236}">
+                <a16:creationId xmlns:a16="http://schemas.microsoft.com/office/drawing/2014/main" id="{C270135E-E36D-48AC-85C3-63AFB38DF72E}"/>
+              </a:ext>
+            </a:extLst>
+          </p:cNvPr>
+          <p:cNvSpPr txBox="1"/>
+          <p:nvPr/>
+        </p:nvSpPr>
+        <p:spPr>
+          <a:xfrm>
+            <a:off x="231628" y="376787"/>
+            <a:ext cx="2246051" cy="369332"/>
+          </a:xfrm>
+          <a:prstGeom prst="rect">
+            <a:avLst/>
+          </a:prstGeom>
+          <a:noFill/>
+        </p:spPr>
+        <p:txBody>
+          <a:bodyPr wrap="square" rtlCol="0">
+            <a:spAutoFit/>
+          </a:bodyPr>
+          <a:lstStyle/>
+          <a:p>
+            <a:r>
+              <a:rPr lang="en-US" altLang="zh-CN" b="1"/>
+              <a:t>Scade</a:t>
+            </a:r>
+            <a:r>
+              <a:rPr lang="zh-CN" altLang="en-US" b="1"/>
+              <a:t>程序</a:t>
+            </a:r>
+          </a:p>
+        </p:txBody>
+      </p:sp>
+      <p:sp>
+        <p:nvSpPr>
+          <p:cNvPr id="9" name="文本框 8">
+            <a:extLst>
+              <a:ext uri="{FF2B5EF4-FFF2-40B4-BE49-F238E27FC236}">
+                <a16:creationId xmlns:a16="http://schemas.microsoft.com/office/drawing/2014/main" id="{82F779CE-245C-430B-ABD2-076BEEDED188}"/>
+              </a:ext>
+            </a:extLst>
+          </p:cNvPr>
+          <p:cNvSpPr txBox="1"/>
+          <p:nvPr/>
+        </p:nvSpPr>
+        <p:spPr>
+          <a:xfrm>
+            <a:off x="319581" y="3929334"/>
+            <a:ext cx="2246051" cy="369332"/>
+          </a:xfrm>
+          <a:prstGeom prst="rect">
+            <a:avLst/>
+          </a:prstGeom>
+          <a:noFill/>
+        </p:spPr>
+        <p:txBody>
+          <a:bodyPr wrap="square" rtlCol="0">
+            <a:spAutoFit/>
+          </a:bodyPr>
+          <a:lstStyle/>
+          <a:p>
+            <a:r>
+              <a:rPr lang="en-US" altLang="zh-CN" b="1"/>
+              <a:t>Scade</a:t>
+            </a:r>
+            <a:r>
+              <a:rPr lang="zh-CN" altLang="en-US" b="1"/>
+              <a:t>对应的文法</a:t>
+            </a:r>
+          </a:p>
+        </p:txBody>
+      </p:sp>
+      <p:sp>
+        <p:nvSpPr>
+          <p:cNvPr id="10" name="文本框 9">
+            <a:extLst>
+              <a:ext uri="{FF2B5EF4-FFF2-40B4-BE49-F238E27FC236}">
+                <a16:creationId xmlns:a16="http://schemas.microsoft.com/office/drawing/2014/main" id="{5B05CA99-12AE-48CE-A5C0-FF19CAB8918C}"/>
+              </a:ext>
+            </a:extLst>
+          </p:cNvPr>
+          <p:cNvSpPr txBox="1"/>
+          <p:nvPr/>
+        </p:nvSpPr>
+        <p:spPr>
+          <a:xfrm>
+            <a:off x="5514497" y="376787"/>
+            <a:ext cx="2246051" cy="369332"/>
+          </a:xfrm>
+          <a:prstGeom prst="rect">
+            <a:avLst/>
+          </a:prstGeom>
+          <a:noFill/>
+        </p:spPr>
+        <p:txBody>
+          <a:bodyPr wrap="square" rtlCol="0">
+            <a:spAutoFit/>
+          </a:bodyPr>
+          <a:lstStyle/>
+          <a:p>
+            <a:r>
+              <a:rPr lang="en-US" altLang="zh-CN" b="1"/>
+              <a:t>Scade</a:t>
+            </a:r>
+            <a:r>
+              <a:rPr lang="zh-CN" altLang="en-US" b="1"/>
+              <a:t>对应的</a:t>
+            </a:r>
+            <a:r>
+              <a:rPr lang="en-US" altLang="zh-CN" b="1"/>
+              <a:t>C</a:t>
+            </a:r>
+            <a:r>
+              <a:rPr lang="zh-CN" altLang="en-US" b="1"/>
+              <a:t>程序</a:t>
+            </a:r>
+          </a:p>
+        </p:txBody>
+      </p:sp>
+    </p:spTree>
+    <p:extLst>
+      <p:ext uri="{BB962C8B-B14F-4D97-AF65-F5344CB8AC3E}">
+        <p14:creationId xmlns:p14="http://schemas.microsoft.com/office/powerpoint/2010/main" val="2441633697"/>
       </p:ext>
     </p:extLst>
   </p:cSld>

</xml_diff>